<commit_message>
Add Windows testing notes, update PPT for Phase 2 review, fix banner encoding
- README: add Windows Notes section under Testing Locally (FTP two-step
  connect, Telnet enable via Admin PowerShell + PowerShell fallback, SSH)
- main.py: replace Unicode arrows/em-dash in banner with ASCII equivalents
  to fix UnicodeEncodeError on Windows cp1252 terminals
- Review_PPT: fix swapped descriptions on Slide 4, add FTP+Telnet to
  Slide 7, fix HTTP port 8080->8888, update Socket.IO/architecture text

Co-Authored-By: Claude Sonnet 4.6 <noreply@anthropic.com>
</commit_message>
<xml_diff>
--- a/Review_PPT (1).pptx
+++ b/Review_PPT (1).pptx
@@ -1304,7 +1304,7 @@
           <a:p>
             <a:fld id="{4AAD347D-5ACD-4C99-B74B-A9C85AD731AF}" type="datetimeFigureOut">
               <a:rPr lang="en-US" smtClean="0"/>
-              <a:t>5/5/2026</a:t>
+              <a:t>5/17/2026</a:t>
             </a:fld>
             <a:endParaRPr lang="en-US" dirty="0"/>
           </a:p>
@@ -1637,7 +1637,7 @@
           <a:p>
             <a:fld id="{4509A250-FF31-4206-8172-F9D3106AACB1}" type="datetimeFigureOut">
               <a:rPr lang="en-US" smtClean="0"/>
-              <a:t>5/5/2026</a:t>
+              <a:t>5/17/2026</a:t>
             </a:fld>
             <a:endParaRPr lang="en-US" dirty="0"/>
           </a:p>
@@ -1834,7 +1834,7 @@
           <a:p>
             <a:fld id="{4509A250-FF31-4206-8172-F9D3106AACB1}" type="datetimeFigureOut">
               <a:rPr lang="en-US" smtClean="0"/>
-              <a:t>5/5/2026</a:t>
+              <a:t>5/17/2026</a:t>
             </a:fld>
             <a:endParaRPr lang="en-US" dirty="0"/>
           </a:p>
@@ -2105,7 +2105,7 @@
           <a:p>
             <a:fld id="{4AAD347D-5ACD-4C99-B74B-A9C85AD731AF}" type="datetimeFigureOut">
               <a:rPr lang="en-US" smtClean="0"/>
-              <a:t>5/5/2026</a:t>
+              <a:t>5/17/2026</a:t>
             </a:fld>
             <a:endParaRPr lang="en-US" dirty="0"/>
           </a:p>
@@ -2534,7 +2534,7 @@
           <a:p>
             <a:fld id="{4AAD347D-5ACD-4C99-B74B-A9C85AD731AF}" type="datetimeFigureOut">
               <a:rPr lang="en-US" smtClean="0"/>
-              <a:t>5/5/2026</a:t>
+              <a:t>5/17/2026</a:t>
             </a:fld>
             <a:endParaRPr lang="en-US" dirty="0"/>
           </a:p>
@@ -3085,7 +3085,7 @@
           <a:p>
             <a:fld id="{4509A250-FF31-4206-8172-F9D3106AACB1}" type="datetimeFigureOut">
               <a:rPr lang="en-US" smtClean="0"/>
-              <a:t>5/5/2026</a:t>
+              <a:t>5/17/2026</a:t>
             </a:fld>
             <a:endParaRPr lang="en-US" dirty="0"/>
           </a:p>
@@ -3876,7 +3876,7 @@
           <a:p>
             <a:fld id="{4509A250-FF31-4206-8172-F9D3106AACB1}" type="datetimeFigureOut">
               <a:rPr lang="en-US" smtClean="0"/>
-              <a:t>5/5/2026</a:t>
+              <a:t>5/17/2026</a:t>
             </a:fld>
             <a:endParaRPr lang="en-US" dirty="0"/>
           </a:p>
@@ -4056,7 +4056,7 @@
           <a:p>
             <a:fld id="{4AAD347D-5ACD-4C99-B74B-A9C85AD731AF}" type="datetimeFigureOut">
               <a:rPr lang="en-US" smtClean="0"/>
-              <a:t>5/5/2026</a:t>
+              <a:t>5/17/2026</a:t>
             </a:fld>
             <a:endParaRPr lang="en-US" dirty="0"/>
           </a:p>
@@ -4241,7 +4241,7 @@
           <a:p>
             <a:fld id="{4AAD347D-5ACD-4C99-B74B-A9C85AD731AF}" type="datetimeFigureOut">
               <a:rPr lang="en-US" smtClean="0"/>
-              <a:t>5/5/2026</a:t>
+              <a:t>5/17/2026</a:t>
             </a:fld>
             <a:endParaRPr lang="en-US" dirty="0"/>
           </a:p>
@@ -4493,7 +4493,7 @@
           <a:p>
             <a:fld id="{4AAD347D-5ACD-4C99-B74B-A9C85AD731AF}" type="datetimeFigureOut">
               <a:rPr lang="en-US" smtClean="0"/>
-              <a:t>5/5/2026</a:t>
+              <a:t>5/17/2026</a:t>
             </a:fld>
             <a:endParaRPr lang="en-US" dirty="0"/>
           </a:p>
@@ -4934,7 +4934,7 @@
           <a:p>
             <a:fld id="{9796027F-7875-4030-9381-8BD8C4F21935}" type="datetimeFigureOut">
               <a:rPr lang="en-US" smtClean="0"/>
-              <a:t>5/5/2026</a:t>
+              <a:t>5/17/2026</a:t>
             </a:fld>
             <a:endParaRPr lang="en-US" dirty="0"/>
           </a:p>
@@ -5172,7 +5172,7 @@
           <a:p>
             <a:fld id="{4AAD347D-5ACD-4C99-B74B-A9C85AD731AF}" type="datetimeFigureOut">
               <a:rPr lang="en-US" smtClean="0"/>
-              <a:t>5/5/2026</a:t>
+              <a:t>5/17/2026</a:t>
             </a:fld>
             <a:endParaRPr lang="en-US" dirty="0"/>
           </a:p>
@@ -5558,7 +5558,7 @@
           <a:p>
             <a:fld id="{4AAD347D-5ACD-4C99-B74B-A9C85AD731AF}" type="datetimeFigureOut">
               <a:rPr lang="en-US" smtClean="0"/>
-              <a:t>5/5/2026</a:t>
+              <a:t>5/17/2026</a:t>
             </a:fld>
             <a:endParaRPr lang="en-US" dirty="0"/>
           </a:p>
@@ -5677,7 +5677,7 @@
           <a:p>
             <a:fld id="{4509A250-FF31-4206-8172-F9D3106AACB1}" type="datetimeFigureOut">
               <a:rPr lang="en-US" smtClean="0"/>
-              <a:t>5/5/2026</a:t>
+              <a:t>5/17/2026</a:t>
             </a:fld>
             <a:endParaRPr lang="en-US" dirty="0"/>
           </a:p>
@@ -5773,7 +5773,7 @@
           <a:p>
             <a:fld id="{4509A250-FF31-4206-8172-F9D3106AACB1}" type="datetimeFigureOut">
               <a:rPr lang="en-US" smtClean="0"/>
-              <a:t>5/5/2026</a:t>
+              <a:t>5/17/2026</a:t>
             </a:fld>
             <a:endParaRPr lang="en-US" dirty="0"/>
           </a:p>
@@ -6027,7 +6027,7 @@
           <a:p>
             <a:fld id="{4AAD347D-5ACD-4C99-B74B-A9C85AD731AF}" type="datetimeFigureOut">
               <a:rPr lang="en-US" smtClean="0"/>
-              <a:t>5/5/2026</a:t>
+              <a:t>5/17/2026</a:t>
             </a:fld>
             <a:endParaRPr lang="en-US" dirty="0"/>
           </a:p>
@@ -6297,7 +6297,7 @@
           <a:p>
             <a:fld id="{4509A250-FF31-4206-8172-F9D3106AACB1}" type="datetimeFigureOut">
               <a:rPr lang="en-US" smtClean="0"/>
-              <a:t>5/5/2026</a:t>
+              <a:t>5/17/2026</a:t>
             </a:fld>
             <a:endParaRPr lang="en-US" dirty="0"/>
           </a:p>
@@ -6701,7 +6701,7 @@
           <a:p>
             <a:fld id="{4AAD347D-5ACD-4C99-B74B-A9C85AD731AF}" type="datetimeFigureOut">
               <a:rPr lang="en-US" smtClean="0"/>
-              <a:t>5/5/2026</a:t>
+              <a:t>5/17/2026</a:t>
             </a:fld>
             <a:endParaRPr lang="en-US" dirty="0"/>
           </a:p>
@@ -7273,7 +7273,18 @@
                 <a:ea typeface="Roboto Slab" pitchFamily="34" charset="-122"/>
                 <a:cs typeface="Roboto Slab" pitchFamily="34" charset="-120"/>
               </a:rPr>
-              <a:t>Cybersecurity Internship — Phase 2 Review</a:t>
+              <a:t>Cybersecurity </a:t>
+            </a:r>
+            <a:r>
+              <a:rPr lang="en-US" sz="3900">
+                <a:solidFill>
+                  <a:srgbClr val="3257B8"/>
+                </a:solidFill>
+                <a:latin typeface="Roboto Slab" pitchFamily="34" charset="0"/>
+                <a:ea typeface="Roboto Slab" pitchFamily="34" charset="-122"/>
+                <a:cs typeface="Roboto Slab" pitchFamily="34" charset="-120"/>
+              </a:rPr>
+              <a:t>Internship —Review</a:t>
             </a:r>
             <a:endParaRPr lang="en-US" sz="3900" dirty="0"/>
           </a:p>
@@ -9561,7 +9572,7 @@
                 <a:ea typeface="Roboto" pitchFamily="34" charset="-122"/>
                 <a:cs typeface="Roboto" pitchFamily="34" charset="-120"/>
               </a:rPr>
-              <a:t>Finished all NetAcad modules covering OSINT recon, active Nmap scanning, Metasploit exploitation, Cyber Kill Chain, vulnerability analysis, and post-exploitation methodology.</a:t>
+              <a:t>Exploited real OWASP Top 10 vulnerabilities: HTML source leakage, JS restriction bypass via DevTools, directory listing, robots.txt disclosure, HTTP Referer header forgery using curl -H, and cookie-based authentication bypass – proving client-side data can never be trusted for authentication.</a:t>
             </a:r>
             <a:endParaRPr lang="en-US" sz="1450" dirty="0"/>
           </a:p>
@@ -9575,7 +9586,7 @@
         </p:nvSpPr>
         <p:spPr>
           <a:xfrm>
-            <a:off x="574118" y="3758158"/>
+            <a:off x="574118" y="3928704"/>
             <a:ext cx="2356842" cy="294680"/>
           </a:xfrm>
           <a:prstGeom prst="rect">
@@ -9743,7 +9754,7 @@
         </p:nvSpPr>
         <p:spPr>
           <a:xfrm>
-            <a:off x="7280552" y="3703569"/>
+            <a:off x="7280552" y="3191422"/>
             <a:ext cx="4205648" cy="294680"/>
           </a:xfrm>
           <a:prstGeom prst="rect">
@@ -9785,7 +9796,7 @@
         </p:nvSpPr>
         <p:spPr>
           <a:xfrm>
-            <a:off x="7315200" y="3984454"/>
+            <a:off x="7315200" y="3472307"/>
             <a:ext cx="6603788" cy="882610"/>
           </a:xfrm>
           <a:prstGeom prst="rect">
@@ -9813,7 +9824,7 @@
                 <a:ea typeface="Roboto" pitchFamily="34" charset="-122"/>
                 <a:cs typeface="Roboto" pitchFamily="34" charset="-120"/>
               </a:rPr>
-              <a:t>Completed the entire Bandit wargame: SSH key auth, encoding, SUID exploitation, cron privilege escalation, restricted shell escape via vi and $0 variable, and full Git forensics across branches, tags, and commit history.</a:t>
+              <a:t>Finished all 7 NetAcad modules covering OSINT recon (Google Dorking, WHOIS, Shodan, theHarvester), active Nmap scanning (SYN, version detection, OS fingerprinting), Metasploit Framework architecture, Cyber Kill Chain, and post-exploitation methodology.</a:t>
             </a:r>
             <a:endParaRPr lang="en-US" sz="1450" dirty="0"/>
           </a:p>
@@ -9827,7 +9838,7 @@
         </p:nvSpPr>
         <p:spPr>
           <a:xfrm>
-            <a:off x="7280552" y="5238999"/>
+            <a:off x="7280552" y="4726852"/>
             <a:ext cx="4064677" cy="294680"/>
           </a:xfrm>
           <a:prstGeom prst="rect">
@@ -9855,7 +9866,7 @@
                 <a:ea typeface="Roboto Slab" pitchFamily="34" charset="-122"/>
                 <a:cs typeface="Roboto Slab" pitchFamily="34" charset="-120"/>
               </a:rPr>
-              <a:t>OverTheWire Bandit — Levels 0–16</a:t>
+              <a:t>OverTheWire Bandit — All 35 Levels</a:t>
             </a:r>
             <a:endParaRPr lang="en-US" sz="1850" dirty="0"/>
           </a:p>
@@ -9869,7 +9880,7 @@
         </p:nvSpPr>
         <p:spPr>
           <a:xfrm>
-            <a:off x="7315200" y="5564586"/>
+            <a:off x="7315200" y="5052439"/>
             <a:ext cx="6657261" cy="791079"/>
           </a:xfrm>
           <a:prstGeom prst="rect">
@@ -9897,7 +9908,7 @@
                 <a:ea typeface="Roboto" pitchFamily="34" charset="-122"/>
                 <a:cs typeface="Roboto" pitchFamily="34" charset="-120"/>
               </a:rPr>
-              <a:t>Exploited HTML source leakage, JS restriction bypass, directory listing, robots.txt disclosure, HTTP Referer forgery, and cookie auth bypass — proving that client-side data can never be trusted for authentication.</a:t>
+              <a:t>Completed all 35 Bandit levels: SSH key authentication, encoding/decoding, SUID binary exploitation, cron-based privilege escalation, restricted shell escape via vi and the $0 variable, and full Git forensics across commit history, branches, and tags.</a:t>
             </a:r>
             <a:endParaRPr lang="en-US" sz="1450" dirty="0"/>
           </a:p>
@@ -9994,7 +10005,7 @@
                 <a:ea typeface="Roboto Slab" pitchFamily="34" charset="-122"/>
                 <a:cs typeface="Roboto Slab" pitchFamily="34" charset="-120"/>
               </a:rPr>
-              <a:t>Work to Be Done — Phase 3 &amp; Beyond</a:t>
+              <a:t>Post-Internship</a:t>
             </a:r>
             <a:endParaRPr lang="en-US" sz="3650" dirty="0"/>
           </a:p>
@@ -11162,7 +11173,7 @@
         <p:spPr>
           <a:xfrm>
             <a:off x="9169478" y="1693902"/>
-            <a:ext cx="4240411" cy="2686050"/>
+            <a:ext cx="4568037" cy="2686050"/>
           </a:xfrm>
           <a:prstGeom prst="roundRect">
             <a:avLst>
@@ -11220,7 +11231,7 @@
         <p:spPr>
           <a:xfrm>
             <a:off x="9439512" y="1895355"/>
-            <a:ext cx="2741890" cy="278963"/>
+            <a:ext cx="3609514" cy="858603"/>
           </a:xfrm>
           <a:prstGeom prst="rect">
             <a:avLst/>
@@ -11718,7 +11729,7 @@
                 <a:ea typeface="Roboto" pitchFamily="34" charset="-122"/>
                 <a:cs typeface="Roboto" pitchFamily="34" charset="-120"/>
               </a:rPr>
-              <a:t>A multi-service honeypot built to capture, log, and visualise real-world attack traffic in real time — featuring three concurrent services and a live threat-intelligence dashboard.</a:t>
+              <a:t>A multi-service honeypot built to capture, log, and visualise real-world attack traffic in real time — featuring four concurrent services and a live threat-intelligence dashboard.</a:t>
             </a:r>
             <a:endParaRPr lang="en-US" sz="1450" dirty="0"/>
           </a:p>
@@ -11789,7 +11800,7 @@
                 <a:ea typeface="Roboto Slab" pitchFamily="34" charset="-122"/>
                 <a:cs typeface="Roboto Slab" pitchFamily="34" charset="-120"/>
               </a:rPr>
-              <a:t>SSH Honeypot</a:t>
+              <a:t>SSH, FTP &amp; Telnet Honeypots</a:t>
             </a:r>
             <a:endParaRPr lang="en-US" sz="1850" dirty="0"/>
           </a:p>
@@ -11831,7 +11842,7 @@
                 <a:ea typeface="Roboto" pitchFamily="34" charset="-122"/>
                 <a:cs typeface="Roboto" pitchFamily="34" charset="-120"/>
               </a:rPr>
-              <a:t>Listens on port 2222, presents a realistic OpenSSH banner, and logs every credential pair attempted by attackers in real time.</a:t>
+              <a:t>Listens on port 2222 (SSH), 2121 (FTP), and 2323 (Telnet) — presents realistic service banners, captures every credential pair attempted across all three protocols, and logs them instantly to the database.</a:t>
             </a:r>
             <a:endParaRPr lang="en-US" sz="1450" dirty="0"/>
           </a:p>
@@ -11915,7 +11926,7 @@
                 <a:ea typeface="Roboto" pitchFamily="34" charset="-122"/>
                 <a:cs typeface="Roboto" pitchFamily="34" charset="-120"/>
               </a:rPr>
-              <a:t>Serves convincing decoy pages (WordPress login, phpMyAdmin, admin panel, .env files) on port 8080 to lure and log probes.</a:t>
+              <a:t>Serves convincing decoy pages (WordPress login, phpMyAdmin, Jenkins, Jupyter, .env files) on port 8888 — fingerprints 13 known scanner tools (Nmap, Masscan, Nikto, Shodan, Censys, sqlmap, Metasploit, and more) and logs every probe with full payload capture.</a:t>
             </a:r>
             <a:endParaRPr lang="en-US" sz="1450" dirty="0"/>
           </a:p>
@@ -11999,7 +12010,7 @@
                 <a:ea typeface="Roboto" pitchFamily="34" charset="-122"/>
                 <a:cs typeface="Roboto" pitchFamily="34" charset="-120"/>
               </a:rPr>
-              <a:t>Flask-powered real-time UI with attack stats, global origin map, hourly timeline, top attacker chart, and credential intelligence feed.</a:t>
+              <a:t>Flask + Socket.IO real-time UI with attack stats, global origin map, hourly timeline, top attacker chart, and credential intelligence feed — events stream instantly via push updates with zero polling delay. Discord &amp; Slack webhook alerts included.</a:t>
             </a:r>
             <a:endParaRPr lang="en-US" sz="1450" dirty="0"/>
           </a:p>
@@ -12306,7 +12317,7 @@
                 <a:ea typeface="Roboto" pitchFamily="34" charset="-122"/>
                 <a:cs typeface="Roboto" pitchFamily="34" charset="-120"/>
               </a:rPr>
-              <a:t>Built entirely in Python — three daemon threads launched from main.py, each handling a distinct attack surface with shared SQLite storage.</a:t>
+              <a:t>Built entirely in Python — five daemon threads launched from main.py, each handling a distinct attack surface with shared SQLite storage.</a:t>
             </a:r>
             <a:endParaRPr lang="en-US" sz="1450" dirty="0"/>
           </a:p>
@@ -12503,7 +12514,7 @@
                 <a:ea typeface="Roboto" pitchFamily="34" charset="-122"/>
                 <a:cs typeface="Roboto" pitchFamily="34" charset="-120"/>
               </a:rPr>
-              <a:t>Two separate Flask apps: one simulates decoy web endpoints; the other exposes a REST API consumed by the live dashboard frontend.</a:t>
+              <a:t>Two separate Flask apps: one simulates SSH/FTP/Telnet/HTTP decoy endpoints; the other exposes REST API endpoints (/api/stats, /api/events, /api/top-credentials) and Socket.IO for real-time event push to the dashboard.</a:t>
             </a:r>
             <a:endParaRPr lang="en-US" sz="1450" dirty="0"/>
           </a:p>
@@ -12587,7 +12598,7 @@
                 <a:ea typeface="Roboto" pitchFamily="34" charset="-122"/>
                 <a:cs typeface="Roboto" pitchFamily="34" charset="-120"/>
               </a:rPr>
-              <a:t>Dashboard built with Chart.js for live charts and Leaflet.js for the attack-origin world map — auto-polling the API every 5 seconds.</a:t>
+              <a:t>Dashboard built with Chart.js for live charts and Leaflet.js for the attack-origin world map — events stream instantly via Socket.IO push (no polling). Scramble/glitch animations and CRT scanlines give it a live threat-intel aesthetic.</a:t>
             </a:r>
             <a:endParaRPr lang="en-US" sz="1450" dirty="0"/>
           </a:p>
@@ -12671,7 +12682,7 @@
                 <a:ea typeface="Roboto" pitchFamily="34" charset="-122"/>
                 <a:cs typeface="Roboto" pitchFamily="34" charset="-120"/>
               </a:rPr>
-              <a:t>Socket programming, multi-threading, REST API design, GeoIP enrichment, SQLite, and full-stack web development — all in one project.</a:t>
+              <a:t>Raw TCP sockets (FTP/Telnet), paramiko SSH server, multi-threading, REST API design, Socket.IO real-time push, GeoIP + ASN enrichment, SQLite with WAL, and full-stack web dev — all in one project.</a:t>
             </a:r>
             <a:endParaRPr lang="en-US" sz="1450" dirty="0"/>
           </a:p>
@@ -13008,7 +13019,7 @@
                 <a:ea typeface="Roboto" pitchFamily="34" charset="-122"/>
                 <a:cs typeface="Roboto" pitchFamily="34" charset="-120"/>
               </a:rPr>
-              <a:t>End-to-end project delivery: the Honeypot System — a production-quality Python tool capturing live attack traffic with SSH + HTTP decoys, GeoIP enrichment, and a real-time dashboard.</a:t>
+              <a:t>End-to-end project delivery: the Honeypot System — a production-quality Python tool capturing live attack traffic with SSH, HTTP, FTP + Telnet decoys, GeoIP enrichment, and a real-time dashboard.</a:t>
             </a:r>
             <a:endParaRPr lang="en-US" sz="1550" dirty="0"/>
           </a:p>

</xml_diff>